<commit_message>
fix(1pager): one title on the slide, and a subtitle that points at four figures
Two things wrong with the slide-1 header.

The subtitle still read "기술문서 2절 그림 1". Section 2 is right, but there is
no single figure 1 any more — it is 1-A, 1-B and 1-C. Now says so, and says the
slide is the overview.

The bigger one: the slide header says "ICLO 근거 레이어 — 데이터 흐름" and the
diagram I embedded said "ICLO 근거 레이어 — 원천에서 기업 화면까지". That exact
duplication was removed once before at the user's request and came back when I
authored a slide-specific sheet with its own title. The sheet's title row is
gone; the slide header is the only one. Extracted text now contains
"근거 레이어" once.

Shifting 40-odd y literals by hand to reclaim the space would have introduced
errors, so start()/finish() take a shift and wrap the content in a translate
group. Canvas 690 -> 642px, slide slot ratio follows.

Co-Authored-By: Claude Opus 5 <noreply@anthropic.com>
</commit_message>
<xml_diff>
--- a/output/pptx/ICLO-근거레이어-1pager-KO.pptx
+++ b/output/pptx/ICLO-근거레이어-1pager-KO.pptx
@@ -3163,7 +3163,7 @@
                 </a:solidFill>
                 <a:latin typeface="Apple SD Gothic Neo"/>
               </a:rPr>
-              <a:t>미국 self-funded employer 치아보험 · 원천에서 화면까지 · 기술문서 2절 그림 1</a:t>
+              <a:t>미국 self-funded employer 치아보험 · 원천에서 기업 화면까지 · 세부는 기술문서 2절 그림 1-A · 1-B · 1-C</a:t>
             </a:r>
           </a:p>
         </p:txBody>
@@ -3268,7 +3268,7 @@
         <p:spPr>
           <a:xfrm>
             <a:off x="384048" y="1060704"/>
-            <a:ext cx="8686800" cy="5079569"/>
+            <a:ext cx="8686800" cy="4726208"/>
           </a:xfrm>
           <a:prstGeom prst="rect">
             <a:avLst/>

</xml_diff>